<commit_message>
add internal architect deck
</commit_message>
<xml_diff>
--- a/docs/community/marketing/decks/architect-phase2a/OCM-Story-Architect-Internal.pptx
+++ b/docs/community/marketing/decks/architect-phase2a/OCM-Story-Architect-Internal.pptx
@@ -2801,26 +2801,6 @@
           <a:lstStyle/>
           <a:p>
             <a:r>
-              <a:rPr lang="de-DE" noProof="1"/>
-              <a:t>Two SAP-shaped paths:</a:t>
-            </a:r>
-            <a:br>
-              <a:rPr lang="de-DE" noProof="1"/>
-            </a:br>
-            <a:endParaRPr lang="de-DE" noProof="1"/>
-          </a:p>
-          <a:p>
-            <a:r>
-              <a:rPr lang="de-DE" noProof="1"/>
-              <a:t>PACK &amp; SHIP: OCM CLI produces component descriptors. RBSC integration with the CLI is live. The 30-minute laptop hands-on is the first half of this card; the production shape is wiring it into the team's release pipeline.</a:t>
-            </a:r>
-            <a:br>
-              <a:rPr lang="de-DE" noProof="1"/>
-            </a:br>
-            <a:endParaRPr lang="de-DE" noProof="1"/>
-          </a:p>
-          <a:p>
-            <a:r>
               <a:rPr lang="de-DE" sz="1200" b="0" i="0" kern="1200" noProof="1">
                 <a:solidFill>
                   <a:schemeClr val="tx1"/>
@@ -2830,52 +2810,11 @@
                 <a:ea typeface="+mn-ea"/>
                 <a:cs typeface="+mn-cs"/>
               </a:rPr>
-              <a:t>DEPLOY &amp; OPERATE: Open Delivery Gear runs compliance and SBOM rollup using the OCM coordinate system. Open Control Plane is the declarative deployment runtime - the long-term replacement for Landscaper.</a:t>
-            </a:r>
-            <a:br>
-              <a:rPr lang="de-DE" noProof="1"/>
-            </a:br>
-            <a:endParaRPr lang="de-DE" noProof="1"/>
-          </a:p>
-          <a:p>
-            <a:r>
-              <a:rPr lang="de-DE" noProof="1"/>
-              <a:t>Q&amp;A backup on Landscaper sunset (Sovereign Cloud audience will ask): Landscaper deploys type-A services (IAS, Audit Log) today in Sovereign Cloud. The migration to Open Control Plane is planned for end-of-year / early next year. OCM components are the SAME on both sides of the migration - only the runtime changes. That is the whole point of the model.</a:t>
-            </a:r>
-            <a:br>
-              <a:rPr lang="de-DE" noProof="1"/>
-            </a:br>
-            <a:endParaRPr lang="de-DE" noProof="1"/>
-          </a:p>
-          <a:p>
-            <a:r>
-              <a:rPr lang="de-DE" noProof="1"/>
-              <a:t>Q&amp;A backup on Hyperspace Piper step (someone will ask if it's not on the slide): Hyperspace integration exists today on OCM v1. The v2 migration is on the 2026 roadmap, not started yet. Internally, Hyperspace already uses OCM for SBOM aggregation. This is why it's on the adopter-proof slide but not as an adoption path - the path is still being built.</a:t>
-            </a:r>
-            <a:br>
-              <a:rPr lang="de-DE" noProof="1"/>
-            </a:br>
-            <a:endParaRPr lang="de-DE" noProof="1"/>
-          </a:p>
-          <a:p>
-            <a:r>
-              <a:rPr lang="de-DE" noProof="1"/>
-              <a:t>Q&amp;A backup on the renames: OCM Gear -&gt; Open Delivery Gear (ODG), now inside the OCM GitHub org. Managed Control Plane -&gt; Open Control Plane, also open source. We hardened the naming when we hardened the projects.</a:t>
-            </a:r>
-          </a:p>
-          <a:p>
-            <a:br>
-              <a:rPr lang="de-DE" sz="1200" kern="1200" noProof="1">
-                <a:solidFill>
-                  <a:schemeClr val="tx1"/>
-                </a:solidFill>
-                <a:effectLst/>
-                <a:latin typeface="+mn-lt"/>
-                <a:ea typeface="+mn-ea"/>
-                <a:cs typeface="+mn-cs"/>
-              </a:rPr>
-            </a:br>
-            <a:endParaRPr lang="de-DE" sz="1200" kern="1200" noProof="1">
+              <a:t>Two paths to a first OCM component. Both tested in conformance on every release.</a:t>
+            </a:r>
+          </a:p>
+          <a:p>
+            <a:endParaRPr lang="de-DE" sz="1200" b="0" i="0" kern="1200" noProof="1">
               <a:solidFill>
                 <a:schemeClr val="tx1"/>
               </a:solidFill>
@@ -2884,6 +2823,70 @@
               <a:ea typeface="+mn-ea"/>
               <a:cs typeface="+mn-cs"/>
             </a:endParaRPr>
+          </a:p>
+          <a:p>
+            <a:r>
+              <a:rPr lang="de-DE" sz="1200" b="0" i="0" kern="1200" noProof="1">
+                <a:solidFill>
+                  <a:schemeClr val="tx1"/>
+                </a:solidFill>
+                <a:effectLst/>
+                <a:latin typeface="+mn-lt"/>
+                <a:ea typeface="+mn-ea"/>
+                <a:cs typeface="+mn-cs"/>
+              </a:rPr>
+              <a:t>From zero, CLI-only. No cluster. Install CLI, write a constructor for one component, pack, sign with RSA, export as CTF, carry to a second machine, import, verify. Cold-start budget: about thirty minutes - CLI install plus the helloworld pack/sign/verify from the website tutorial. Recommend this path first.</a:t>
+            </a:r>
+          </a:p>
+          <a:p>
+            <a:endParaRPr lang="de-DE" sz="1200" b="0" i="0" kern="1200" noProof="1">
+              <a:solidFill>
+                <a:schemeClr val="tx1"/>
+              </a:solidFill>
+              <a:effectLst/>
+              <a:latin typeface="+mn-lt"/>
+              <a:ea typeface="+mn-ea"/>
+              <a:cs typeface="+mn-cs"/>
+            </a:endParaRPr>
+          </a:p>
+          <a:p>
+            <a:r>
+              <a:rPr lang="de-DE" sz="1200" b="0" i="0" kern="1200" noProof="1">
+                <a:solidFill>
+                  <a:schemeClr val="tx1"/>
+                </a:solidFill>
+                <a:effectLst/>
+                <a:latin typeface="+mn-lt"/>
+                <a:ea typeface="+mn-ea"/>
+                <a:cs typeface="+mn-cs"/>
+              </a:rPr>
+              <a:t>On your cluster, controllers. Spin up a kind cluster. Helm-install the OCM controllers, plus kro, plus Flux or Argo CD. Point them at your registry. Apply a Component resource - verified and reconciling. Cold-start budget: an afternoon, including bootstrap (kind + controllers + kro + Flux or Argo CD) and a Helm-deploy of the simple component in the getting-started tutorial.</a:t>
+            </a:r>
+          </a:p>
+          <a:p>
+            <a:endParaRPr lang="de-DE" sz="1200" b="0" i="0" kern="1200" noProof="1">
+              <a:solidFill>
+                <a:schemeClr val="tx1"/>
+              </a:solidFill>
+              <a:effectLst/>
+              <a:latin typeface="+mn-lt"/>
+              <a:ea typeface="+mn-ea"/>
+              <a:cs typeface="+mn-cs"/>
+            </a:endParaRPr>
+          </a:p>
+          <a:p>
+            <a:r>
+              <a:rPr lang="de-DE" sz="1200" b="0" i="0" kern="1200" noProof="1">
+                <a:solidFill>
+                  <a:schemeClr val="tx1"/>
+                </a:solidFill>
+                <a:effectLst/>
+                <a:latin typeface="+mn-lt"/>
+                <a:ea typeface="+mn-ea"/>
+                <a:cs typeface="+mn-cs"/>
+              </a:rPr>
+              <a:t>Both paths coexist with cosign, Argo CD, Flux, Kyverno - whatever you already run. OCM signs the descriptor; existing controls stay in place.</a:t>
+            </a:r>
           </a:p>
         </p:txBody>
       </p:sp>
@@ -3262,7 +3265,7 @@
           <a:p>
             <a:r>
               <a:rPr lang="en-US" noProof="1"/>
-              <a:t>Adopter proof, two columns. The exec-internal deck splits this across two slides; we combine into one for the architect-track audience.</a:t>
+              <a:t>Adopter proof, two columns.</a:t>
             </a:r>
             <a:br>
               <a:rPr lang="en-US" noProof="1"/>
@@ -3316,7 +3319,7 @@
           <a:p>
             <a:r>
               <a:rPr lang="en-US" noProof="1"/>
-              <a:t>Q&amp;A backup on conspicuous absences: ACD, Hana Cloud / SGSC traceability - these were in the 2024 plan but have not made the same progress. We don't claim them as adopters; we claim them as 'considering / in conversation.' Better to under-claim than over-claim.</a:t>
+              <a:t>Q&amp;A backup on conspicuous absences: ACD, Hana Cloud / SGSC traceability - these were in the 2024 plan but have not made the same progress. We don't claim them as adopters; we claim them as 'considering / in conversation.' We don't claim adopters we don't have.</a:t>
             </a:r>
           </a:p>
         </p:txBody>
@@ -3553,7 +3556,7 @@
           <a:p>
             <a:r>
               <a:rPr lang="en-US" noProof="1"/>
-              <a:t>A fifth controller, `Replication Controller`, sits alongside the four-card chain - not within it. Where the chain delivers content INTO the cluster, Replication transfers a resolved component version FROM one OCM repository TO another.</a:t>
+              <a:t>A fifth controller, 'Replication Controller', sits alongside the four-card chain - not within it. Where the chain delivers content INTO the cluster, Replication transfers a resolved component version FROM one OCM repository TO another.</a:t>
             </a:r>
           </a:p>
           <a:p>
@@ -3568,7 +3571,7 @@
           <a:p>
             <a:r>
               <a:rPr lang="en-US" noProof="1"/>
-              <a:t>References a source `Component` CR and a target `Repository` CR. When the resolved version of a source changes, transfers that version with its full reference graph into the target.</a:t>
+              <a:t>References a source 'Component' CR and a target 'Repository' CR. When the resolved version of a source changes, transfers that version with its full reference graph into the target.</a:t>
             </a:r>
           </a:p>
           <a:p>
@@ -3577,7 +3580,7 @@
             </a:br>
             <a:r>
               <a:rPr lang="en-US" noProof="1"/>
-              <a:t>Mirrors the behavior of `ocm transfer cv` on the OCM CLI. Records `status.lastTransferredDigest` after each successful run; a later reconciliation seeing the same digest is a no-op.</a:t>
+              <a:t>Mirrors the behavior of 'ocm transfer cv' on the OCM CLI. Records 'status.lastTransferredDigest' after each successful run; a later reconciliation seeing the same digest is a no-op.</a:t>
             </a:r>
           </a:p>
           <a:p>
@@ -3848,7 +3851,7 @@
                 <a:ea typeface="+mn-ea"/>
                 <a:cs typeface="+mn-cs"/>
               </a:rPr>
-              <a:t>Calibration for the cosign audience: cosign updates the digest after an explicit `cosign copy`. Keeps signing each piece. What's missing is a name for the release as one unit - signable, verifiable in a sovereign zone with no callback.</a:t>
+              <a:t>Calibration for the cosign audience: cosign updates the digest after an explicit 'cosign copy'. Keeps signing each piece. What's missing is a name for the release as one unit - signable, verifiable in a sovereign zone with no callback.</a:t>
             </a:r>
           </a:p>
           <a:p>
@@ -4469,31 +4472,31 @@
           <a:p>
             <a:r>
               <a:rPr lang="en-US" noProof="1"/>
-              <a:t>• `components` - list, usually one. Name is DNS-style; version is SemVer.</a:t>
+              <a:t>• 'components' - list, usually one. Name is DNS-style; version is SemVer.</a:t>
             </a:r>
           </a:p>
           <a:p>
             <a:r>
               <a:rPr lang="en-US" noProof="1"/>
-              <a:t>• `provider` - metadata, required.</a:t>
+              <a:t>• 'provider' - metadata, required.</a:t>
             </a:r>
           </a:p>
           <a:p>
             <a:r>
               <a:rPr lang="en-US" noProof="1"/>
-              <a:t>• `resources` - every artifact in the release. Two ways in:</a:t>
+              <a:t>• 'resources' - every artifact in the release. Two ways in:</a:t>
             </a:r>
           </a:p>
           <a:p>
             <a:r>
               <a:rPr lang="en-US" noProof="1"/>
-              <a:t>  ▪ `input:` - by value. Constructor reads the file at pack time, embeds the bytes. Travels in the archive.</a:t>
+              <a:t>  ▪ 'input:' - by value. Constructor reads the file at pack time, embeds the bytes. Travels in the archive.</a:t>
             </a:r>
           </a:p>
           <a:p>
             <a:r>
               <a:rPr lang="en-US" noProof="1"/>
-              <a:t>  ▪ `access:` - by reference. Records a pointer (e.g. `ghcr.io/.../podinfo:6.9.1`), resolves digest now, copies bytes later.</a:t>
+              <a:t>  ▪ 'access:' - by reference. Records a pointer (e.g. 'ghcr.io/.../podinfo:6.9.1'), resolves digest now, copies bytes later.</a:t>
             </a:r>
           </a:p>
           <a:p>
@@ -4508,7 +4511,7 @@
           <a:p>
             <a:r>
               <a:rPr lang="en-US" noProof="1"/>
-              <a:t>CLI if asked: `ocm add cv` against this file, default output a CTF archive.</a:t>
+              <a:t>CLI if asked: 'ocm add cv' against this file, default output a CTF archive.</a:t>
             </a:r>
           </a:p>
         </p:txBody>
@@ -9004,7 +9007,7 @@
           <a:p>
             <a:fld id="{5BCAD085-E8A6-8845-BD4E-CB4CCA059FC4}" type="datetimeFigureOut">
               <a:rPr lang="en-US" smtClean="0"/>
-              <a:t>7/1/2026</a:t>
+              <a:t>7/3/26</a:t>
             </a:fld>
             <a:endParaRPr lang="en-US"/>
           </a:p>
@@ -9082,7 +9085,7 @@
           <a:p>
             <a:fld id="{C1FF6DA9-008F-8B48-92A6-B652298478BF}" type="slidenum">
               <a:rPr lang="en-US" smtClean="0"/>
-              <a:t>‹#›</a:t>
+              <a:t>‹Nr.›</a:t>
             </a:fld>
             <a:endParaRPr lang="en-US"/>
           </a:p>
@@ -9645,7 +9648,7 @@
           <a:p>
             <a:r>
               <a:rPr lang="en-US" noProof="1"/>
-              <a:t>Three patterns. One command.</a:t>
+              <a:t>Same command, three shapes</a:t>
             </a:r>
           </a:p>
         </p:txBody>
@@ -11031,22 +11034,21 @@
             <p:ph type="title" idx="2"/>
           </p:nvPr>
         </p:nvSpPr>
-        <p:spPr/>
+        <p:spPr>
+          <a:xfrm>
+            <a:off x="1143000" y="1238250"/>
+            <a:ext cx="16529858" cy="952500"/>
+          </a:xfrm>
+        </p:spPr>
         <p:txBody>
           <a:bodyPr>
-            <a:normAutofit fontScale="90000"/>
+            <a:noAutofit/>
           </a:bodyPr>
           <a:lstStyle/>
           <a:p>
             <a:r>
-              <a:rPr lang="en-US" noProof="1"/>
-              <a:t>Bump the product version.</a:t>
-            </a:r>
-          </a:p>
-          <a:p>
-            <a:r>
-              <a:rPr lang="en-US" noProof="1"/>
-              <a:t>Everything follows.</a:t>
+              <a:rPr lang="en-US" sz="5800" noProof="1"/>
+              <a:t>Bump the product version and the references follow.</a:t>
             </a:r>
           </a:p>
         </p:txBody>
@@ -13336,8 +13338,8 @@
         </p:nvSpPr>
         <p:spPr>
           <a:xfrm>
-            <a:off x="914400" y="4381500"/>
-            <a:ext cx="16192500" cy="1614854"/>
+            <a:off x="1047750" y="4476750"/>
+            <a:ext cx="16192500" cy="2563004"/>
           </a:xfrm>
         </p:spPr>
         <p:txBody>
@@ -13350,7 +13352,7 @@
                   <a:srgbClr val="5CD6FF"/>
                 </a:solidFill>
               </a:rPr>
-              <a:t>Evaluate</a:t>
+              <a:t>Pilot</a:t>
             </a:r>
             <a:r>
               <a:rPr lang="en-US" noProof="1">
@@ -13358,8 +13360,17 @@
                   <a:srgbClr val="FFFFFF"/>
                 </a:solidFill>
               </a:rPr>
-              <a:t> - ocm.software (QR code) · run conformance/scenarios/sovereign</a:t>
-            </a:r>
+              <a:t> - </a:t>
+            </a:r>
+            <a:r>
+              <a:rPr lang="en-US" noProof="1"/>
+              <a:t>pack one product this quarter · in your team's pipeline</a:t>
+            </a:r>
+            <a:endParaRPr lang="en-US" noProof="1">
+              <a:solidFill>
+                <a:srgbClr val="FFFFFF"/>
+              </a:solidFill>
+            </a:endParaRPr>
           </a:p>
           <a:p>
             <a:r>
@@ -13368,7 +13379,7 @@
                   <a:srgbClr val="5CD6FF"/>
                 </a:solidFill>
               </a:rPr>
-              <a:t>Pilot</a:t>
+              <a:t>Standardize</a:t>
             </a:r>
             <a:r>
               <a:rPr lang="en-US" noProof="1">
@@ -13376,8 +13387,17 @@
                   <a:srgbClr val="FFFFFF"/>
                 </a:solidFill>
               </a:rPr>
-              <a:t> - github.com/open-component-model · one product, one team</a:t>
-            </a:r>
+              <a:t> - </a:t>
+            </a:r>
+            <a:r>
+              <a:rPr lang="en-US" noProof="1"/>
+              <a:t>make OCM the default in your LoB · bottom-up, not mandate</a:t>
+            </a:r>
+            <a:endParaRPr lang="en-US" noProof="1">
+              <a:solidFill>
+                <a:srgbClr val="FFFFFF"/>
+              </a:solidFill>
+            </a:endParaRPr>
           </a:p>
           <a:p>
             <a:r>
@@ -13386,16 +13406,20 @@
                   <a:srgbClr val="5CD6FF"/>
                 </a:solidFill>
               </a:rPr>
-              <a:t>Engage</a:t>
-            </a:r>
-            <a:r>
-              <a:rPr lang="en-US" noProof="1">
-                <a:solidFill>
-                  <a:srgbClr val="FFFFFF"/>
-                </a:solidFill>
-              </a:rPr>
-              <a:t> - community channels on the website · NeoNephos Foundation</a:t>
-            </a:r>
+              <a:t>Steward</a:t>
+            </a:r>
+            <a:r>
+              <a:rPr lang="en-US" noProof="1"/>
+              <a:t> - Slack #sap-tech-ocm · Community Calls every four weeks</a:t>
+            </a:r>
+            <a:br>
+              <a:rPr lang="en-US" noProof="1"/>
+            </a:br>
+            <a:endParaRPr lang="en-US" noProof="1">
+              <a:solidFill>
+                <a:srgbClr val="FFFFFF"/>
+              </a:solidFill>
+            </a:endParaRPr>
           </a:p>
         </p:txBody>
       </p:sp>
@@ -13594,7 +13618,7 @@
                 </a:solidFill>
                 <a:latin typeface="Aptos"/>
               </a:rPr>
-              <a:t>Controller-shaped equivalent of OCM CLI `ocm transfer cv` - point it at a source `Component` and a target `Repository`, and it keeps them in sync.</a:t>
+              <a:t>Controller-shaped equivalent of OCM CLI  ‘ocm ansfer cv’ - point it at a source ’Component’ and a target ‘Repository’, and it keeps them in sync.</a:t>
             </a:r>
           </a:p>
         </p:txBody>
@@ -20604,12 +20628,14 @@
           </a:xfrm>
         </p:spPr>
         <p:txBody>
-          <a:bodyPr/>
+          <a:bodyPr>
+            <a:normAutofit fontScale="90000"/>
+          </a:bodyPr>
           <a:lstStyle/>
           <a:p>
             <a:r>
               <a:rPr lang="en-US" noProof="1"/>
-              <a:t>Same signed object. Three signing options.</a:t>
+              <a:t>One signed object, three ways to prove the key.</a:t>
             </a:r>
           </a:p>
         </p:txBody>
@@ -21318,6 +21344,15 @@
 </file>
 
 <file path=customXml/item1.xml><?xml version="1.0" encoding="utf-8"?>
+<?mso-contentType ?>
+<FormTemplates xmlns="http://schemas.microsoft.com/sharepoint/v3/contenttype/forms">
+  <Display>DocumentLibraryForm</Display>
+  <Edit>DocumentLibraryForm</Edit>
+  <New>DocumentLibraryForm</New>
+</FormTemplates>
+</file>
+
+<file path=customXml/item2.xml><?xml version="1.0" encoding="utf-8"?>
 <ct:contentTypeSchema xmlns:ct="http://schemas.microsoft.com/office/2006/metadata/contentType" xmlns:ma="http://schemas.microsoft.com/office/2006/metadata/properties/metaAttributes" ct:_="" ma:_="" ma:contentTypeName="Document" ma:contentTypeID="0x01010017EFA48812873240AA97B5B839318D37" ma:contentTypeVersion="14" ma:contentTypeDescription="Create a new document." ma:contentTypeScope="" ma:versionID="6876bea24b9e57681f192b07c4a8c5f0">
   <xsd:schema xmlns:xsd="http://www.w3.org/2001/XMLSchema" xmlns:xs="http://www.w3.org/2001/XMLSchema" xmlns:p="http://schemas.microsoft.com/office/2006/metadata/properties" xmlns:ns2="ba6d13f6-f01e-4a65-ae09-5a5653d84bec" xmlns:ns3="05b660bb-c4f4-43c1-874c-d1e089478096" targetNamespace="http://schemas.microsoft.com/office/2006/metadata/properties" ma:root="true" ma:fieldsID="ae0a213070a59abd7af7dac0ab70f7d1" ns2:_="" ns3:_="">
     <xsd:import namespace="ba6d13f6-f01e-4a65-ae09-5a5653d84bec"/>
@@ -21546,15 +21581,6 @@
 </ct:contentTypeSchema>
 </file>
 
-<file path=customXml/item2.xml><?xml version="1.0" encoding="utf-8"?>
-<?mso-contentType ?>
-<FormTemplates xmlns="http://schemas.microsoft.com/sharepoint/v3/contenttype/forms">
-  <Display>DocumentLibraryForm</Display>
-  <Edit>DocumentLibraryForm</Edit>
-  <New>DocumentLibraryForm</New>
-</FormTemplates>
-</file>
-
 <file path=customXml/item3.xml><?xml version="1.0" encoding="utf-8"?>
 <p:properties xmlns:p="http://schemas.microsoft.com/office/2006/metadata/properties" xmlns:xsi="http://www.w3.org/2001/XMLSchema-instance" xmlns:pc="http://schemas.microsoft.com/office/infopath/2007/PartnerControls">
   <documentManagement>
@@ -21567,6 +21593,14 @@
 </file>
 
 <file path=customXml/itemProps1.xml><?xml version="1.0" encoding="utf-8"?>
+<ds:datastoreItem xmlns:ds="http://schemas.openxmlformats.org/officeDocument/2006/customXml" ds:itemID="{65DB66EA-42DF-41D5-9F1B-3D3FBC8E70F4}">
+  <ds:schemaRefs>
+    <ds:schemaRef ds:uri="http://schemas.microsoft.com/sharepoint/v3/contenttype/forms"/>
+  </ds:schemaRefs>
+</ds:datastoreItem>
+</file>
+
+<file path=customXml/itemProps2.xml><?xml version="1.0" encoding="utf-8"?>
 <ds:datastoreItem xmlns:ds="http://schemas.openxmlformats.org/officeDocument/2006/customXml" ds:itemID="{BC23BCFA-AB34-4321-9CF6-D03FE9A2563E}">
   <ds:schemaRefs>
     <ds:schemaRef ds:uri="05b660bb-c4f4-43c1-874c-d1e089478096"/>
@@ -21581,14 +21615,6 @@
     <ds:schemaRef ds:uri="http://schemas.microsoft.com/office/infopath/2007/PartnerControls"/>
     <ds:schemaRef ds:uri="http://schemas.openxmlformats.org/package/2006/metadata/core-properties"/>
     <ds:schemaRef ds:uri="http://www.w3.org/2001/XMLSchema"/>
-  </ds:schemaRefs>
-</ds:datastoreItem>
-</file>
-
-<file path=customXml/itemProps2.xml><?xml version="1.0" encoding="utf-8"?>
-<ds:datastoreItem xmlns:ds="http://schemas.openxmlformats.org/officeDocument/2006/customXml" ds:itemID="{65DB66EA-42DF-41D5-9F1B-3D3FBC8E70F4}">
-  <ds:schemaRefs>
-    <ds:schemaRef ds:uri="http://schemas.microsoft.com/sharepoint/v3/contenttype/forms"/>
   </ds:schemaRefs>
 </ds:datastoreItem>
 </file>

</xml_diff>